<commit_message>
Presentations: second review pass — plainer headlines, no other proposals
The owner: managers and colleagues will not see the draft proposals, so
nothing compares Familiar Nine with them.

- Managers' "Why Familiar Nine?" is now six plain reasons and the one
  trade-off (late finishes), not a table against Right Away and All Clear.
- "Where it stands" no longer counts how many proposals meet the rules.
- Colleague slides lose the small print (the precision is in the notes):
  "Contracted days at work", pay answered by the 35-hour week, Sundays
  "about the same as today", "More staff on the floor", and "avoidable
  tiring patterns" in place of ORR terminology.
- Plain translations beside figures: weekends "one in four, not one in
  five", late finishes "one extra every 2-3 weeks".

No figure changed.

Co-Authored-By: Claude Opus 5.5 <noreply@anthropic.com>
Claude-Session: https://claude.ai/code/session_01MrfcTRinN39zgr6tpkue66
</commit_message>
<xml_diff>
--- a/docs/proposals/presentations/Familiar-Nine-for-colleagues.pptx
+++ b/docs/proposals/presentations/Familiar-Nine-for-colleagues.pptx
@@ -604,7 +604,7 @@
           <a:p>
             <a:r>
               <a:rPr lang="en-US" dirty="0"/>
-              <a:t>Earlies here means a start before 11:00. Sundays: today 8 Sunday duties across 16 working weeks, Familiar Nine 10 across 20 — the same one-in-two share.</a:t>
+              <a:t>Earlies here means a start before 11:00. Sundays: today 8 Sunday duties across 16 working weeks, Familiar Nine 10 across 20 — the same one-in-two share of working weeks. Because cover weeks come round a little less often, that is about one more Sunday a year each (22 against 21).</a:t>
             </a:r>
             <a:endParaRPr lang="en-US" dirty="0"/>
           </a:p>
@@ -1308,7 +1308,7 @@
           <a:p>
             <a:r>
               <a:rPr lang="en-US" dirty="0"/>
-              <a:t>Monday to Saturday, counting a cover week as four days worked, the same way the clerks do. Sundays are overtime by agreement, so they are not in these figures — today or in Familiar Nine. Fewer days is possible because the average shift is a few minutes longer, which is the next slide.</a:t>
+              <a:t>Monday to Saturday, counting a cover week as four days worked, the same way the clerks do. Sundays are overtime by agreement, so they are not in these figures — today or in Familiar Nine. If asked: counting Sunday overtime too, it is about one fewer day a year rather than two. 32 days is the standard CEA contract. Fewer days is possible because the average shift is a few minutes longer, which is the next slide.</a:t>
             </a:r>
             <a:endParaRPr lang="en-US" dirty="0"/>
           </a:p>
@@ -2699,7 +2699,7 @@
                 <a:ea typeface="Inter" pitchFamily="34" charset="-122"/>
                 <a:cs typeface="Inter" pitchFamily="34" charset="-120"/>
               </a:rPr>
-              <a:t>Not part of the contract, same as now — one Sunday every other working week, as today (about one more a year each).</a:t>
+              <a:t>Not part of the contract, same as now — and about the same number of Sundays as today.</a:t>
             </a:r>
             <a:endParaRPr lang="en-US" sz="1300" dirty="0"/>
           </a:p>
@@ -3898,7 +3898,7 @@
                 <a:ea typeface="Inter" pitchFamily="34" charset="-122"/>
                 <a:cs typeface="Inter" pitchFamily="34" charset="-120"/>
               </a:rPr>
-              <a:t>More colleagues around you</a:t>
+              <a:t>More staff on the floor</a:t>
             </a:r>
             <a:endParaRPr lang="en-US" sz="3000" dirty="0"/>
           </a:p>
@@ -3937,7 +3937,7 @@
                 <a:ea typeface="Inter" pitchFamily="34" charset="-122"/>
                 <a:cs typeface="Inter" pitchFamily="34" charset="-120"/>
               </a:rPr>
-              <a:t>More people on duty, and fewer tiring patterns in the rota</a:t>
+              <a:t>More people on duty with you, all day</a:t>
             </a:r>
             <a:endParaRPr lang="en-US" sz="1500" dirty="0"/>
           </a:p>
@@ -3951,8 +3951,8 @@
         </p:nvSpPr>
         <p:spPr>
           <a:xfrm>
-            <a:off x="4846320" y="1417320"/>
-            <a:ext cx="1920240" cy="320040"/>
+            <a:off x="4297680" y="1417320"/>
+            <a:ext cx="2194560" cy="320040"/>
           </a:xfrm>
           <a:prstGeom prst="rect">
             <a:avLst/>
@@ -3990,8 +3990,8 @@
         </p:nvSpPr>
         <p:spPr>
           <a:xfrm>
-            <a:off x="6766560" y="1417320"/>
-            <a:ext cx="1920240" cy="320040"/>
+            <a:off x="6492240" y="1417320"/>
+            <a:ext cx="2194560" cy="320040"/>
           </a:xfrm>
           <a:prstGeom prst="rect">
             <a:avLst/>
@@ -4057,7 +4057,7 @@
         <p:spPr>
           <a:xfrm>
             <a:off x="640080" y="1801368"/>
-            <a:ext cx="4206240" cy="475488"/>
+            <a:ext cx="3657600" cy="475488"/>
           </a:xfrm>
           <a:prstGeom prst="rect">
             <a:avLst/>
@@ -4095,8 +4095,8 @@
         </p:nvSpPr>
         <p:spPr>
           <a:xfrm>
-            <a:off x="4846320" y="1801368"/>
-            <a:ext cx="1920240" cy="475488"/>
+            <a:off x="4297680" y="1801368"/>
+            <a:ext cx="2194560" cy="475488"/>
           </a:xfrm>
           <a:prstGeom prst="rect">
             <a:avLst/>
@@ -4134,8 +4134,8 @@
         </p:nvSpPr>
         <p:spPr>
           <a:xfrm>
-            <a:off x="6766560" y="1801368"/>
-            <a:ext cx="1920240" cy="475488"/>
+            <a:off x="6492240" y="1801368"/>
+            <a:ext cx="2194560" cy="475488"/>
           </a:xfrm>
           <a:prstGeom prst="rect">
             <a:avLst/>
@@ -4201,7 +4201,7 @@
         <p:spPr>
           <a:xfrm>
             <a:off x="640080" y="2368296"/>
-            <a:ext cx="4206240" cy="475488"/>
+            <a:ext cx="3657600" cy="475488"/>
           </a:xfrm>
           <a:prstGeom prst="rect">
             <a:avLst/>
@@ -4239,8 +4239,8 @@
         </p:nvSpPr>
         <p:spPr>
           <a:xfrm>
-            <a:off x="4846320" y="2368296"/>
-            <a:ext cx="1920240" cy="475488"/>
+            <a:off x="4297680" y="2368296"/>
+            <a:ext cx="2194560" cy="475488"/>
           </a:xfrm>
           <a:prstGeom prst="rect">
             <a:avLst/>
@@ -4278,8 +4278,8 @@
         </p:nvSpPr>
         <p:spPr>
           <a:xfrm>
-            <a:off x="6766560" y="2368296"/>
-            <a:ext cx="1920240" cy="475488"/>
+            <a:off x="6492240" y="2368296"/>
+            <a:ext cx="2194560" cy="475488"/>
           </a:xfrm>
           <a:prstGeom prst="rect">
             <a:avLst/>
@@ -4345,7 +4345,7 @@
         <p:spPr>
           <a:xfrm>
             <a:off x="640080" y="2935224"/>
-            <a:ext cx="4206240" cy="475488"/>
+            <a:ext cx="3657600" cy="475488"/>
           </a:xfrm>
           <a:prstGeom prst="rect">
             <a:avLst/>
@@ -4383,8 +4383,8 @@
         </p:nvSpPr>
         <p:spPr>
           <a:xfrm>
-            <a:off x="4846320" y="2935224"/>
-            <a:ext cx="1920240" cy="475488"/>
+            <a:off x="4297680" y="2935224"/>
+            <a:ext cx="2194560" cy="475488"/>
           </a:xfrm>
           <a:prstGeom prst="rect">
             <a:avLst/>
@@ -4422,8 +4422,8 @@
         </p:nvSpPr>
         <p:spPr>
           <a:xfrm>
-            <a:off x="6766560" y="2935224"/>
-            <a:ext cx="1920240" cy="475488"/>
+            <a:off x="6492240" y="2935224"/>
+            <a:ext cx="2194560" cy="475488"/>
           </a:xfrm>
           <a:prstGeom prst="rect">
             <a:avLst/>
@@ -4489,7 +4489,7 @@
         <p:spPr>
           <a:xfrm>
             <a:off x="640080" y="3502152"/>
-            <a:ext cx="4206240" cy="475488"/>
+            <a:ext cx="3657600" cy="475488"/>
           </a:xfrm>
           <a:prstGeom prst="rect">
             <a:avLst/>
@@ -4513,7 +4513,7 @@
                 <a:ea typeface="Inter" pitchFamily="34" charset="-122"/>
                 <a:cs typeface="Inter" pitchFamily="34" charset="-120"/>
               </a:rPr>
-              <a:t>Tiring patterns caused by the design (ORR list)</a:t>
+              <a:t>Avoidable tiring patterns in the rota</a:t>
             </a:r>
             <a:endParaRPr lang="en-US" sz="1400" dirty="0"/>
           </a:p>
@@ -4527,8 +4527,8 @@
         </p:nvSpPr>
         <p:spPr>
           <a:xfrm>
-            <a:off x="4846320" y="3502152"/>
-            <a:ext cx="1920240" cy="475488"/>
+            <a:off x="4297680" y="3502152"/>
+            <a:ext cx="2194560" cy="475488"/>
           </a:xfrm>
           <a:prstGeom prst="rect">
             <a:avLst/>
@@ -4566,8 +4566,8 @@
         </p:nvSpPr>
         <p:spPr>
           <a:xfrm>
-            <a:off x="6766560" y="3502152"/>
-            <a:ext cx="1920240" cy="475488"/>
+            <a:off x="6492240" y="3502152"/>
+            <a:ext cx="2194560" cy="475488"/>
           </a:xfrm>
           <a:prstGeom prst="rect">
             <a:avLst/>
@@ -4666,45 +4666,6 @@
       <p:sp>
         <p:nvSpPr>
           <p:cNvPr id="24" name="Text 22"/>
-          <p:cNvSpPr txBox="1"/>
-          <p:nvPr/>
-        </p:nvSpPr>
-        <p:spPr>
-          <a:xfrm>
-            <a:off x="4023360" y="4754880"/>
-            <a:ext cx="4663440" cy="310896"/>
-          </a:xfrm>
-          <a:prstGeom prst="rect">
-            <a:avLst/>
-          </a:prstGeom>
-          <a:noFill/>
-          <a:ln/>
-        </p:spPr>
-        <p:txBody>
-          <a:bodyPr wrap="square" lIns="0" tIns="0" rIns="0" bIns="0" rtlCol="0" anchor="t"/>
-          <a:lstStyle/>
-          <a:p>
-            <a:pPr algn="r" indent="0" marL="0">
-              <a:buNone/>
-            </a:pPr>
-            <a:r>
-              <a:rPr lang="en-US" sz="850" i="1" dirty="0">
-                <a:solidFill>
-                  <a:srgbClr val="5B6778"/>
-                </a:solidFill>
-                <a:latin typeface="Inter" pitchFamily="34" charset="0"/>
-                <a:ea typeface="Inter" pitchFamily="34" charset="-122"/>
-                <a:cs typeface="Inter" pitchFamily="34" charset="-120"/>
-              </a:rPr>
-              <a:t>Not counted: early starts and weekly rotation, which every link has. Not a risk assessment.</a:t>
-            </a:r>
-            <a:endParaRPr lang="en-US" sz="850" dirty="0"/>
-          </a:p>
-        </p:txBody>
-      </p:sp>
-      <p:sp>
-        <p:nvSpPr>
-          <p:cNvPr id="25" name="Text 23"/>
           <p:cNvSpPr txBox="1"/>
           <p:nvPr/>
         </p:nvSpPr>
@@ -6076,7 +6037,7 @@
                           <a:ea typeface="Inter" pitchFamily="34" charset="-122"/>
                           <a:cs typeface="Inter" pitchFamily="34" charset="-120"/>
                         </a:rPr>
-                        <a:t>Days at work a year, not counting Sundays</a:t>
+                        <a:t>Contracted days at work a year</a:t>
                       </a:r>
                       <a:endParaRPr lang="en-US" sz="1200" dirty="0">
                         <a:latin typeface="Inter" charset="0"/>
@@ -6762,7 +6723,7 @@
                           <a:ea typeface="Inter" pitchFamily="34" charset="-122"/>
                           <a:cs typeface="Inter" pitchFamily="34" charset="-120"/>
                         </a:rPr>
-                        <a:t>4 in 20</a:t>
+                        <a:t>4 in 20 (one in five)</a:t>
                       </a:r>
                       <a:endParaRPr lang="en-US" sz="1200" dirty="0">
                         <a:latin typeface="Inter" charset="0"/>
@@ -6830,7 +6791,7 @@
                           <a:ea typeface="Inter" pitchFamily="34" charset="-122"/>
                           <a:cs typeface="Inter" pitchFamily="34" charset="-120"/>
                         </a:rPr>
-                        <a:t>6 in 24</a:t>
+                        <a:t>6 in 24 (one in four)</a:t>
                       </a:r>
                       <a:endParaRPr lang="en-US" sz="1200" dirty="0">
                         <a:latin typeface="Inter" charset="0"/>
@@ -7724,7 +7685,7 @@
                           <a:ea typeface="Inter" pitchFamily="34" charset="-122"/>
                           <a:cs typeface="Inter" pitchFamily="34" charset="-120"/>
                         </a:rPr>
-                        <a:t>Tiring patterns caused by the design (ORR)</a:t>
+                        <a:t>Avoidable tiring patterns in the rota</a:t>
                       </a:r>
                       <a:endParaRPr lang="en-US" sz="1200" dirty="0">
                         <a:latin typeface="Inter" charset="0"/>
@@ -8810,7 +8771,7 @@
                 <a:ea typeface="Inter" pitchFamily="34" charset="-122"/>
                 <a:cs typeface="Inter" pitchFamily="34" charset="-120"/>
               </a:rPr>
-              <a:t>today 4 in 20</a:t>
+              <a:t>one in four, not one in five</a:t>
             </a:r>
             <a:endParaRPr lang="en-US" sz="1200" dirty="0"/>
           </a:p>
@@ -9988,8 +9949,8 @@
         </p:nvSpPr>
         <p:spPr>
           <a:xfrm>
-            <a:off x="4846320" y="1417320"/>
-            <a:ext cx="1920240" cy="320040"/>
+            <a:off x="4297680" y="1417320"/>
+            <a:ext cx="2194560" cy="320040"/>
           </a:xfrm>
           <a:prstGeom prst="rect">
             <a:avLst/>
@@ -10027,8 +9988,8 @@
         </p:nvSpPr>
         <p:spPr>
           <a:xfrm>
-            <a:off x="6766560" y="1417320"/>
-            <a:ext cx="1920240" cy="320040"/>
+            <a:off x="6492240" y="1417320"/>
+            <a:ext cx="2194560" cy="320040"/>
           </a:xfrm>
           <a:prstGeom prst="rect">
             <a:avLst/>
@@ -10094,7 +10055,7 @@
         <p:spPr>
           <a:xfrm>
             <a:off x="640080" y="1801368"/>
-            <a:ext cx="4206240" cy="475488"/>
+            <a:ext cx="3657600" cy="475488"/>
           </a:xfrm>
           <a:prstGeom prst="rect">
             <a:avLst/>
@@ -10132,8 +10093,8 @@
         </p:nvSpPr>
         <p:spPr>
           <a:xfrm>
-            <a:off x="4846320" y="1801368"/>
-            <a:ext cx="1920240" cy="475488"/>
+            <a:off x="4297680" y="1801368"/>
+            <a:ext cx="2194560" cy="475488"/>
           </a:xfrm>
           <a:prstGeom prst="rect">
             <a:avLst/>
@@ -10171,8 +10132,8 @@
         </p:nvSpPr>
         <p:spPr>
           <a:xfrm>
-            <a:off x="6766560" y="1801368"/>
-            <a:ext cx="1920240" cy="475488"/>
+            <a:off x="6492240" y="1801368"/>
+            <a:ext cx="2194560" cy="475488"/>
           </a:xfrm>
           <a:prstGeom prst="rect">
             <a:avLst/>
@@ -10238,7 +10199,7 @@
         <p:spPr>
           <a:xfrm>
             <a:off x="640080" y="2368296"/>
-            <a:ext cx="4206240" cy="475488"/>
+            <a:ext cx="3657600" cy="475488"/>
           </a:xfrm>
           <a:prstGeom prst="rect">
             <a:avLst/>
@@ -10262,7 +10223,7 @@
                 <a:ea typeface="Inter" pitchFamily="34" charset="-122"/>
                 <a:cs typeface="Inter" pitchFamily="34" charset="-120"/>
               </a:rPr>
-              <a:t>Days at work a week, not counting Sundays</a:t>
+              <a:t>Contracted days at work a week</a:t>
             </a:r>
             <a:endParaRPr lang="en-US" sz="1400" dirty="0"/>
           </a:p>
@@ -10276,8 +10237,8 @@
         </p:nvSpPr>
         <p:spPr>
           <a:xfrm>
-            <a:off x="4846320" y="2368296"/>
-            <a:ext cx="1920240" cy="475488"/>
+            <a:off x="4297680" y="2368296"/>
+            <a:ext cx="2194560" cy="475488"/>
           </a:xfrm>
           <a:prstGeom prst="rect">
             <a:avLst/>
@@ -10315,8 +10276,8 @@
         </p:nvSpPr>
         <p:spPr>
           <a:xfrm>
-            <a:off x="6766560" y="2368296"/>
-            <a:ext cx="1920240" cy="475488"/>
+            <a:off x="6492240" y="2368296"/>
+            <a:ext cx="2194560" cy="475488"/>
           </a:xfrm>
           <a:prstGeom prst="rect">
             <a:avLst/>
@@ -10382,7 +10343,7 @@
         <p:spPr>
           <a:xfrm>
             <a:off x="640080" y="2935224"/>
-            <a:ext cx="4206240" cy="475488"/>
+            <a:ext cx="3657600" cy="475488"/>
           </a:xfrm>
           <a:prstGeom prst="rect">
             <a:avLst/>
@@ -10406,7 +10367,7 @@
                 <a:ea typeface="Inter" pitchFamily="34" charset="-122"/>
                 <a:cs typeface="Inter" pitchFamily="34" charset="-120"/>
               </a:rPr>
-              <a:t>Days at work a year, not counting Sundays</a:t>
+              <a:t>Contracted days at work a year</a:t>
             </a:r>
             <a:endParaRPr lang="en-US" sz="1400" dirty="0"/>
           </a:p>
@@ -10420,8 +10381,8 @@
         </p:nvSpPr>
         <p:spPr>
           <a:xfrm>
-            <a:off x="4846320" y="2935224"/>
-            <a:ext cx="1920240" cy="475488"/>
+            <a:off x="4297680" y="2935224"/>
+            <a:ext cx="2194560" cy="475488"/>
           </a:xfrm>
           <a:prstGeom prst="rect">
             <a:avLst/>
@@ -10459,8 +10420,8 @@
         </p:nvSpPr>
         <p:spPr>
           <a:xfrm>
-            <a:off x="6766560" y="2935224"/>
-            <a:ext cx="1920240" cy="475488"/>
+            <a:off x="6492240" y="2935224"/>
+            <a:ext cx="2194560" cy="475488"/>
           </a:xfrm>
           <a:prstGeom prst="rect">
             <a:avLst/>
@@ -10526,7 +10487,7 @@
         <p:spPr>
           <a:xfrm>
             <a:off x="640080" y="3502152"/>
-            <a:ext cx="4206240" cy="475488"/>
+            <a:ext cx="3657600" cy="475488"/>
           </a:xfrm>
           <a:prstGeom prst="rect">
             <a:avLst/>
@@ -10550,7 +10511,7 @@
                 <a:ea typeface="Inter" pitchFamily="34" charset="-122"/>
                 <a:cs typeface="Inter" pitchFamily="34" charset="-120"/>
               </a:rPr>
-              <a:t>… after 32 days’ leave (standard CEA contract)</a:t>
+              <a:t>… after 32 days’ annual leave</a:t>
             </a:r>
             <a:endParaRPr lang="en-US" sz="1400" dirty="0"/>
           </a:p>
@@ -10564,8 +10525,8 @@
         </p:nvSpPr>
         <p:spPr>
           <a:xfrm>
-            <a:off x="4846320" y="3502152"/>
-            <a:ext cx="1920240" cy="475488"/>
+            <a:off x="4297680" y="3502152"/>
+            <a:ext cx="2194560" cy="475488"/>
           </a:xfrm>
           <a:prstGeom prst="rect">
             <a:avLst/>
@@ -10603,8 +10564,8 @@
         </p:nvSpPr>
         <p:spPr>
           <a:xfrm>
-            <a:off x="6766560" y="3502152"/>
-            <a:ext cx="1920240" cy="475488"/>
+            <a:off x="6492240" y="3502152"/>
+            <a:ext cx="2194560" cy="475488"/>
           </a:xfrm>
           <a:prstGeom prst="rect">
             <a:avLst/>
@@ -10703,45 +10664,6 @@
       <p:sp>
         <p:nvSpPr>
           <p:cNvPr id="24" name="Text 22"/>
-          <p:cNvSpPr txBox="1"/>
-          <p:nvPr/>
-        </p:nvSpPr>
-        <p:spPr>
-          <a:xfrm>
-            <a:off x="4023360" y="4754880"/>
-            <a:ext cx="4663440" cy="310896"/>
-          </a:xfrm>
-          <a:prstGeom prst="rect">
-            <a:avLst/>
-          </a:prstGeom>
-          <a:noFill/>
-          <a:ln/>
-        </p:spPr>
-        <p:txBody>
-          <a:bodyPr wrap="square" lIns="0" tIns="0" rIns="0" bIns="0" rtlCol="0" anchor="t"/>
-          <a:lstStyle/>
-          <a:p>
-            <a:pPr algn="r" indent="0" marL="0">
-              <a:buNone/>
-            </a:pPr>
-            <a:r>
-              <a:rPr lang="en-US" sz="850" i="1" dirty="0">
-                <a:solidFill>
-                  <a:srgbClr val="5B6778"/>
-                </a:solidFill>
-                <a:latin typeface="Inter" pitchFamily="34" charset="0"/>
-                <a:ea typeface="Inter" pitchFamily="34" charset="-122"/>
-                <a:cs typeface="Inter" pitchFamily="34" charset="-120"/>
-              </a:rPr>
-              <a:t>Sunday overtime not counted; with it, about 1 fewer day a year.</a:t>
-            </a:r>
-            <a:endParaRPr lang="en-US" sz="850" dirty="0"/>
-          </a:p>
-        </p:txBody>
-      </p:sp>
-      <p:sp>
-        <p:nvSpPr>
-          <p:cNvPr id="25" name="Text 23"/>
           <p:cNvSpPr txBox="1"/>
           <p:nvPr/>
         </p:nvSpPr>
@@ -10882,7 +10804,7 @@
                 <a:ea typeface="Inter" pitchFamily="34" charset="-122"/>
                 <a:cs typeface="Inter" pitchFamily="34" charset="-120"/>
               </a:rPr>
-              <a:t>Your basic pay follows your contracted hours — and they do not change</a:t>
+              <a:t>Your pay follows your contracted hours</a:t>
             </a:r>
             <a:endParaRPr lang="en-US" sz="1500" dirty="0"/>
           </a:p>
@@ -11458,7 +11380,7 @@
                 <a:ea typeface="Inter" pitchFamily="34" charset="-122"/>
                 <a:cs typeface="Inter" pitchFamily="34" charset="-120"/>
               </a:rPr>
-              <a:t>No — basic pay stays the same, plus about four more Saturdays at time and a quarter.</a:t>
+              <a:t>No. The same 35-hour week — plus about four more Saturdays at time and a quarter.</a:t>
             </a:r>
             <a:endParaRPr lang="en-US" sz="1400" dirty="0"/>
           </a:p>
@@ -11467,45 +11389,6 @@
       <p:sp>
         <p:nvSpPr>
           <p:cNvPr id="20" name="Text 18"/>
-          <p:cNvSpPr txBox="1"/>
-          <p:nvPr/>
-        </p:nvSpPr>
-        <p:spPr>
-          <a:xfrm>
-            <a:off x="4023360" y="4754880"/>
-            <a:ext cx="4663440" cy="310896"/>
-          </a:xfrm>
-          <a:prstGeom prst="rect">
-            <a:avLst/>
-          </a:prstGeom>
-          <a:noFill/>
-          <a:ln/>
-        </p:spPr>
-        <p:txBody>
-          <a:bodyPr wrap="square" lIns="0" tIns="0" rIns="0" bIns="0" rtlCol="0" anchor="t"/>
-          <a:lstStyle/>
-          <a:p>
-            <a:pPr algn="r" indent="0" marL="0">
-              <a:buNone/>
-            </a:pPr>
-            <a:r>
-              <a:rPr lang="en-US" sz="850" i="1" dirty="0">
-                <a:solidFill>
-                  <a:srgbClr val="5B6778"/>
-                </a:solidFill>
-                <a:latin typeface="Inter" pitchFamily="34" charset="0"/>
-                <a:ea typeface="Inter" pitchFamily="34" charset="-122"/>
-                <a:cs typeface="Inter" pitchFamily="34" charset="-120"/>
-              </a:rPr>
-              <a:t>Link averages, not a payslip: overtime and absence change what you earn.</a:t>
-            </a:r>
-            <a:endParaRPr lang="en-US" sz="850" dirty="0"/>
-          </a:p>
-        </p:txBody>
-      </p:sp>
-      <p:sp>
-        <p:nvSpPr>
-          <p:cNvPr id="21" name="Text 19"/>
           <p:cNvSpPr txBox="1"/>
           <p:nvPr/>
         </p:nvSpPr>
@@ -13388,45 +13271,6 @@
       <p:sp>
         <p:nvSpPr>
           <p:cNvPr id="24" name="Text 22"/>
-          <p:cNvSpPr txBox="1"/>
-          <p:nvPr/>
-        </p:nvSpPr>
-        <p:spPr>
-          <a:xfrm>
-            <a:off x="4023360" y="4754880"/>
-            <a:ext cx="4663440" cy="310896"/>
-          </a:xfrm>
-          <a:prstGeom prst="rect">
-            <a:avLst/>
-          </a:prstGeom>
-          <a:noFill/>
-          <a:ln/>
-        </p:spPr>
-        <p:txBody>
-          <a:bodyPr wrap="square" lIns="0" tIns="0" rIns="0" bIns="0" rtlCol="0" anchor="t"/>
-          <a:lstStyle/>
-          <a:p>
-            <a:pPr algn="r" indent="0" marL="0">
-              <a:buNone/>
-            </a:pPr>
-            <a:r>
-              <a:rPr lang="en-US" sz="850" i="1" dirty="0">
-                <a:solidFill>
-                  <a:srgbClr val="5B6778"/>
-                </a:solidFill>
-                <a:latin typeface="Inter" pitchFamily="34" charset="0"/>
-                <a:ea typeface="Inter" pitchFamily="34" charset="-122"/>
-                <a:cs typeface="Inter" pitchFamily="34" charset="-120"/>
-              </a:rPr>
-              <a:t>Each person, averaged across the whole link.</a:t>
-            </a:r>
-            <a:endParaRPr lang="en-US" sz="850" dirty="0"/>
-          </a:p>
-        </p:txBody>
-      </p:sp>
-      <p:sp>
-        <p:nvSpPr>
-          <p:cNvPr id="25" name="Text 23"/>
           <p:cNvSpPr txBox="1"/>
           <p:nvPr/>
         </p:nvSpPr>

</xml_diff>

<commit_message>
Proposals: rebuild the download pack for the 12 sheets; ship the updated Familiar Nine decks
The zip still held 25 sheets, including every one withdrawn today, and the
earlier Right Away and Familiar Nine. It now holds the current 12 sheets
and import files, the regenerated summary, the rules, both technical
notes, and the Familiar Nine presentations as rebuilt for its better
Sunday (F9-24-K31s, Sunday fit 26.4) — which had been built but never
copied into presentations/. Read me first says 12.

Co-Authored-By: Claude Opus 5.5 <noreply@anthropic.com>
Claude-Session: https://claude.ai/code/session_01MrfcTRinN39zgr6tpkue66
</commit_message>
<xml_diff>
--- a/docs/proposals/presentations/Familiar-Nine-for-colleagues.pptx
+++ b/docs/proposals/presentations/Familiar-Nine-for-colleagues.pptx
@@ -1132,7 +1132,7 @@
           <a:p>
             <a:r>
               <a:rPr lang="en-US" dirty="0"/>
-              <a:t>This is the whole pitch on one slide. Same 35-hour week as now. Never more than six days in a row. One full weekend off in every four weeks, against one in five today. Nine of the fifteen shift times are ones people already work. And every closing shift is shorter: the weekday and Saturday closers by 30 minutes, the Sunday closer by 45.</a:t>
+              <a:t>This is the whole pitch on one slide. Same 35-hour week as now. Never more than six days in a row. One full weekend off in every four weeks, against one in five today. Eight of the sixteen shift times are ones people already work. And every closing shift is shorter: the weekday and Saturday closers by 30 minutes, the Sunday closer by 45.</a:t>
             </a:r>
             <a:endParaRPr lang="en-US" dirty="0"/>
           </a:p>
@@ -1660,7 +1660,7 @@
           <a:p>
             <a:r>
               <a:rPr lang="en-US" dirty="0"/>
-              <a:t>Familiar Nine was built specifically to keep the times people already work wherever that cost little. Nine of its fifteen are worked today, and it uses fewer different times overall than today’s eighteen.</a:t>
+              <a:t>Familiar Nine was built specifically to keep the times people already work wherever that cost little. Eight of its sixteen are worked today, and it uses fewer different times overall than today’s eighteen.</a:t>
             </a:r>
             <a:endParaRPr lang="en-US" dirty="0"/>
           </a:p>
@@ -2281,7 +2281,7 @@
                 <a:ea typeface="Inter" pitchFamily="34" charset="-122"/>
                 <a:cs typeface="Inter" pitchFamily="34" charset="-120"/>
               </a:rPr>
-              <a:t>A proposal for discussion · CEA link · 24 weeks · code F9-24-K31</a:t>
+              <a:t>A proposal for discussion · CEA link · 24 weeks · code F9-24-K31s</a:t>
             </a:r>
             <a:endParaRPr lang="en-US" sz="1300" dirty="0"/>
           </a:p>
@@ -4872,7 +4872,7 @@
                 <a:ea typeface="Inter" pitchFamily="34" charset="-122"/>
                 <a:cs typeface="Inter" pitchFamily="34" charset="-120"/>
               </a:rPr>
-              <a:t>Six new shift times to learn</a:t>
+              <a:t>Eight new shift times to learn</a:t>
             </a:r>
             <a:endParaRPr lang="en-US" sz="1400" dirty="0"/>
           </a:p>
@@ -7409,7 +7409,7 @@
                           <a:ea typeface="Inter" pitchFamily="34" charset="-122"/>
                           <a:cs typeface="Inter" pitchFamily="34" charset="-120"/>
                         </a:rPr>
-                        <a:t>15 (9 you know)</a:t>
+                        <a:t>16 (8 you know)</a:t>
                       </a:r>
                       <a:endParaRPr lang="en-US" sz="1200" dirty="0">
                         <a:latin typeface="Inter" charset="0"/>
@@ -8223,7 +8223,7 @@
                 <a:ea typeface="Inter" pitchFamily="34" charset="-122"/>
                 <a:cs typeface="Inter" pitchFamily="34" charset="-120"/>
               </a:rPr>
-              <a:t>Familiar Nine · F9-24-K31 · every figure worked out from the rota by the Marylebone Roster app</a:t>
+              <a:t>Familiar Nine · F9-24-K31s · every figure worked out from the rota by the Marylebone Roster app</a:t>
             </a:r>
             <a:endParaRPr lang="en-US" sz="1200" dirty="0"/>
           </a:p>
@@ -8839,7 +8839,7 @@
                 <a:ea typeface="Inter" pitchFamily="34" charset="-122"/>
                 <a:cs typeface="Inter" pitchFamily="34" charset="-120"/>
               </a:rPr>
-              <a:t>9 of 15</a:t>
+              <a:t>8 of 16</a:t>
             </a:r>
             <a:endParaRPr lang="en-US" sz="3000" dirty="0"/>
           </a:p>
@@ -8917,7 +8917,7 @@
                 <a:ea typeface="Inter" pitchFamily="34" charset="-122"/>
                 <a:cs typeface="Inter" pitchFamily="34" charset="-120"/>
               </a:rPr>
-              <a:t>only 6 new ones</a:t>
+              <a:t>8 new ones</a:t>
             </a:r>
             <a:endParaRPr lang="en-US" sz="1200" dirty="0"/>
           </a:p>
@@ -13267,7 +13267,7 @@
                 <a:ea typeface="Inter" pitchFamily="34" charset="-122"/>
                 <a:cs typeface="Inter" pitchFamily="34" charset="-120"/>
               </a:rPr>
-              <a:t>15 shift times in all — 9 of them you already work</a:t>
+              <a:t>16 shift times in all — 8 of them you already work</a:t>
             </a:r>
             <a:endParaRPr lang="en-US" sz="1500" dirty="0"/>
           </a:p>
@@ -13382,7 +13382,7 @@
                 <a:ea typeface="Inter" pitchFamily="34" charset="-122"/>
                 <a:cs typeface="Inter" pitchFamily="34" charset="-120"/>
               </a:rPr>
-              <a:t>You work these today (9)</a:t>
+              <a:t>You work these today (8)</a:t>
             </a:r>
             <a:endParaRPr lang="en-US" sz="1500" dirty="0"/>
           </a:p>
@@ -13446,7 +13446,7 @@
                 <a:ea typeface="Inter" pitchFamily="34" charset="-122"/>
                 <a:cs typeface="Inter" pitchFamily="34" charset="-120"/>
               </a:rPr>
-              <a:t>06:20–14:50 · 08:30–16:30</a:t>
+              <a:t>06:20–14:50 · 13:30–21:00</a:t>
             </a:r>
             <a:endParaRPr lang="en-US" sz="1200" dirty="0"/>
           </a:p>
@@ -13467,7 +13467,7 @@
                 <a:ea typeface="Inter" pitchFamily="34" charset="-122"/>
                 <a:cs typeface="Inter" pitchFamily="34" charset="-120"/>
               </a:rPr>
-              <a:t>13:30–21:00 · 14:00–22:30</a:t>
+              <a:t>14:00–22:30 · 14:30–22:00</a:t>
             </a:r>
             <a:endParaRPr lang="en-US" sz="1200" dirty="0"/>
           </a:p>
@@ -13488,28 +13488,7 @@
                 <a:ea typeface="Inter" pitchFamily="34" charset="-122"/>
                 <a:cs typeface="Inter" pitchFamily="34" charset="-120"/>
               </a:rPr>
-              <a:t>14:30–22:00 · 14:30–23:25</a:t>
-            </a:r>
-            <a:endParaRPr lang="en-US" sz="1200" dirty="0"/>
-          </a:p>
-          <a:p>
-            <a:pPr marL="342900" indent="-342900">
-              <a:spcAft>
-                <a:spcPts val="200"/>
-              </a:spcAft>
-              <a:buSzPct val="100000"/>
-              <a:buChar char="•"/>
-            </a:pPr>
-            <a:r>
-              <a:rPr lang="en-US" sz="1200" dirty="0">
-                <a:solidFill>
-                  <a:srgbClr val="1B2533"/>
-                </a:solidFill>
-                <a:latin typeface="Inter" pitchFamily="34" charset="0"/>
-                <a:ea typeface="Inter" pitchFamily="34" charset="-122"/>
-                <a:cs typeface="Inter" pitchFamily="34" charset="-120"/>
-              </a:rPr>
-              <a:t>15:15–23:55</a:t>
+              <a:t>14:30–23:25 · 15:15–23:55</a:t>
             </a:r>
             <a:endParaRPr lang="en-US" sz="1200" dirty="0"/>
           </a:p>
@@ -13624,7 +13603,7 @@
                 <a:ea typeface="Inter" pitchFamily="34" charset="-122"/>
                 <a:cs typeface="Inter" pitchFamily="34" charset="-120"/>
               </a:rPr>
-              <a:t>New times (6)</a:t>
+              <a:t>New times (8)</a:t>
             </a:r>
             <a:endParaRPr lang="en-US" sz="1500" dirty="0"/>
           </a:p>
@@ -13658,7 +13637,7 @@
               <a:buNone/>
             </a:pPr>
             <a:r>
-              <a:rPr lang="en-US" sz="1200" b="1" dirty="0">
+              <a:rPr lang="en-US" sz="1050" b="1" dirty="0">
                 <a:solidFill>
                   <a:srgbClr val="001E3C"/>
                 </a:solidFill>
@@ -13668,18 +13647,18 @@
               </a:rPr>
               <a:t>Weekdays</a:t>
             </a:r>
-            <a:endParaRPr lang="en-US" sz="1200" dirty="0"/>
+            <a:endParaRPr lang="en-US" sz="1050" dirty="0"/>
           </a:p>
           <a:p>
             <a:pPr marL="342900" indent="-342900">
               <a:spcAft>
-                <a:spcPts val="200"/>
+                <a:spcPts val="100"/>
               </a:spcAft>
               <a:buSzPct val="100000"/>
               <a:buChar char="•"/>
             </a:pPr>
             <a:r>
-              <a:rPr lang="en-US" sz="1200" dirty="0">
+              <a:rPr lang="en-US" sz="1050" dirty="0">
                 <a:solidFill>
                   <a:srgbClr val="1B2533"/>
                 </a:solidFill>
@@ -13689,18 +13668,18 @@
               </a:rPr>
               <a:t>07:00–16:00 — a new early</a:t>
             </a:r>
-            <a:endParaRPr lang="en-US" sz="1200" dirty="0"/>
+            <a:endParaRPr lang="en-US" sz="1050" dirty="0"/>
           </a:p>
           <a:p>
             <a:pPr marL="342900" indent="-342900">
               <a:spcAft>
-                <a:spcPts val="200"/>
+                <a:spcPts val="100"/>
               </a:spcAft>
               <a:buSzPct val="100000"/>
               <a:buChar char="•"/>
             </a:pPr>
             <a:r>
-              <a:rPr lang="en-US" sz="1200" dirty="0">
+              <a:rPr lang="en-US" sz="1050" dirty="0">
                 <a:solidFill>
                   <a:srgbClr val="1B2533"/>
                 </a:solidFill>
@@ -13710,7 +13689,7 @@
               </a:rPr>
               <a:t>15:45–23:55 — the closer, 30 minutes later than 15:15</a:t>
             </a:r>
-            <a:endParaRPr lang="en-US" sz="1200" dirty="0"/>
+            <a:endParaRPr lang="en-US" sz="1050" dirty="0"/>
           </a:p>
           <a:p>
             <a:pPr indent="0" marL="0">
@@ -13723,7 +13702,7 @@
               <a:buNone/>
             </a:pPr>
             <a:r>
-              <a:rPr lang="en-US" sz="1200" b="1" dirty="0">
+              <a:rPr lang="en-US" sz="1050" b="1" dirty="0">
                 <a:solidFill>
                   <a:srgbClr val="001E3C"/>
                 </a:solidFill>
@@ -13733,18 +13712,18 @@
               </a:rPr>
               <a:t>Saturday</a:t>
             </a:r>
-            <a:endParaRPr lang="en-US" sz="1200" dirty="0"/>
+            <a:endParaRPr lang="en-US" sz="1050" dirty="0"/>
           </a:p>
           <a:p>
             <a:pPr marL="342900" indent="-342900">
               <a:spcAft>
-                <a:spcPts val="200"/>
+                <a:spcPts val="100"/>
               </a:spcAft>
               <a:buSzPct val="100000"/>
               <a:buChar char="•"/>
             </a:pPr>
             <a:r>
-              <a:rPr lang="en-US" sz="1200" dirty="0">
+              <a:rPr lang="en-US" sz="1050" dirty="0">
                 <a:solidFill>
                   <a:srgbClr val="1B2533"/>
                 </a:solidFill>
@@ -13754,18 +13733,18 @@
               </a:rPr>
               <a:t>06:20–15:00 — ten minutes on from 06:20–14:50</a:t>
             </a:r>
-            <a:endParaRPr lang="en-US" sz="1200" dirty="0"/>
+            <a:endParaRPr lang="en-US" sz="1050" dirty="0"/>
           </a:p>
           <a:p>
             <a:pPr marL="342900" indent="-342900">
               <a:spcAft>
-                <a:spcPts val="200"/>
+                <a:spcPts val="100"/>
               </a:spcAft>
               <a:buSzPct val="100000"/>
               <a:buChar char="•"/>
             </a:pPr>
             <a:r>
-              <a:rPr lang="en-US" sz="1200" dirty="0">
+              <a:rPr lang="en-US" sz="1050" dirty="0">
                 <a:solidFill>
                   <a:srgbClr val="1B2533"/>
                 </a:solidFill>
@@ -13775,7 +13754,7 @@
               </a:rPr>
               <a:t>07:30–16:30 — a new early</a:t>
             </a:r>
-            <a:endParaRPr lang="en-US" sz="1200" dirty="0"/>
+            <a:endParaRPr lang="en-US" sz="1050" dirty="0"/>
           </a:p>
           <a:p>
             <a:pPr indent="0" marL="0">
@@ -13788,7 +13767,7 @@
               <a:buNone/>
             </a:pPr>
             <a:r>
-              <a:rPr lang="en-US" sz="1200" b="1" dirty="0">
+              <a:rPr lang="en-US" sz="1050" b="1" dirty="0">
                 <a:solidFill>
                   <a:srgbClr val="001E3C"/>
                 </a:solidFill>
@@ -13798,18 +13777,18 @@
               </a:rPr>
               <a:t>Sunday</a:t>
             </a:r>
-            <a:endParaRPr lang="en-US" sz="1200" dirty="0"/>
+            <a:endParaRPr lang="en-US" sz="1050" dirty="0"/>
           </a:p>
           <a:p>
             <a:pPr marL="342900" indent="-342900">
               <a:spcAft>
-                <a:spcPts val="200"/>
+                <a:spcPts val="100"/>
               </a:spcAft>
               <a:buSzPct val="100000"/>
               <a:buChar char="•"/>
             </a:pPr>
             <a:r>
-              <a:rPr lang="en-US" sz="1200" dirty="0">
+              <a:rPr lang="en-US" sz="1050" dirty="0">
                 <a:solidFill>
                   <a:srgbClr val="1B2533"/>
                 </a:solidFill>
@@ -13819,18 +13798,18 @@
               </a:rPr>
               <a:t>07:15–15:30 — the opener, 15 minutes shorter</a:t>
             </a:r>
-            <a:endParaRPr lang="en-US" sz="1200" dirty="0"/>
+            <a:endParaRPr lang="en-US" sz="1050" dirty="0"/>
           </a:p>
           <a:p>
             <a:pPr marL="342900" indent="-342900">
               <a:spcAft>
-                <a:spcPts val="200"/>
+                <a:spcPts val="100"/>
               </a:spcAft>
               <a:buSzPct val="100000"/>
               <a:buChar char="•"/>
             </a:pPr>
             <a:r>
-              <a:rPr lang="en-US" sz="1200" dirty="0">
+              <a:rPr lang="en-US" sz="1050" dirty="0">
                 <a:solidFill>
                   <a:srgbClr val="1B2533"/>
                 </a:solidFill>
@@ -13840,7 +13819,49 @@
               </a:rPr>
               <a:t>15:15–23:25 — the closer, 45 minutes later than 14:30</a:t>
             </a:r>
-            <a:endParaRPr lang="en-US" sz="1200" dirty="0"/>
+            <a:endParaRPr lang="en-US" sz="1050" dirty="0"/>
+          </a:p>
+          <a:p>
+            <a:pPr marL="342900" indent="-342900">
+              <a:spcAft>
+                <a:spcPts val="100"/>
+              </a:spcAft>
+              <a:buSzPct val="100000"/>
+              <a:buChar char="•"/>
+            </a:pPr>
+            <a:r>
+              <a:rPr lang="en-US" sz="1050" dirty="0">
+                <a:solidFill>
+                  <a:srgbClr val="1B2533"/>
+                </a:solidFill>
+                <a:latin typeface="Inter" pitchFamily="34" charset="0"/>
+                <a:ea typeface="Inter" pitchFamily="34" charset="-122"/>
+                <a:cs typeface="Inter" pitchFamily="34" charset="-120"/>
+              </a:rPr>
+              <a:t>09:00–18:00 — a new mid-day shift</a:t>
+            </a:r>
+            <a:endParaRPr lang="en-US" sz="1050" dirty="0"/>
+          </a:p>
+          <a:p>
+            <a:pPr marL="342900" indent="-342900">
+              <a:spcAft>
+                <a:spcPts val="100"/>
+              </a:spcAft>
+              <a:buSzPct val="100000"/>
+              <a:buChar char="•"/>
+            </a:pPr>
+            <a:r>
+              <a:rPr lang="en-US" sz="1050" dirty="0">
+                <a:solidFill>
+                  <a:srgbClr val="1B2533"/>
+                </a:solidFill>
+                <a:latin typeface="Inter" pitchFamily="34" charset="0"/>
+                <a:ea typeface="Inter" pitchFamily="34" charset="-122"/>
+                <a:cs typeface="Inter" pitchFamily="34" charset="-120"/>
+              </a:rPr>
+              <a:t>14:30–22:30 — the ticket-office late</a:t>
+            </a:r>
+            <a:endParaRPr lang="en-US" sz="1050" dirty="0"/>
           </a:p>
         </p:txBody>
       </p:sp>
@@ -13904,7 +13925,7 @@
                 <a:ea typeface="Inter" pitchFamily="34" charset="-122"/>
                 <a:cs typeface="Inter" pitchFamily="34" charset="-120"/>
               </a:rPr>
-              <a:t>Fewer shift times than today (15, not 18) — and most new ones are a small nudge.</a:t>
+              <a:t>Fewer shift times than today (16, not 18) — and most new ones are a small nudge.</a:t>
             </a:r>
             <a:endParaRPr lang="en-US" sz="1400" dirty="0"/>
           </a:p>

</xml_diff>

<commit_message>
Familiar Nine decks: fixes from a screenshot check of every slide
- Bullets sat far from their text on the two card slides (colleague 8,
  managers 8) and the closing slide; the indent is now tight.
- Row labels that wrapped to two lines are shortened: "Weeks on one turn,
  Monday to Friday" (colleague 9); the managers' fatigue rows. The 13-day
  limit's unconfirmed source moves into the slide's footnote, not lost.
- The managers' train-fit answer fits one line.
- "December rules", not "December staffing rules" — not all nine are
  staffing levels (managers 2, 7, 10).
- Times read "8h 40m", as the sheets and the summary now do.
No figure changes (text of both decks compared). The zip is rebuilt.

Co-Authored-By: Claude Opus 5.5 <noreply@anthropic.com>
Claude-Session: https://claude.ai/code/session_01MrfcTRinN39zgr6tpkue66
</commit_message>
<xml_diff>
--- a/docs/proposals/presentations/Familiar-Nine-for-colleagues.pptx
+++ b/docs/proposals/presentations/Familiar-Nine-for-colleagues.pptx
@@ -1484,7 +1484,7 @@
           <a:p>
             <a:r>
               <a:rPr lang="en-US" dirty="0"/>
-              <a:t>Lead with the closers: they are the shifts people dislike most, and every one of them is shorter. Weekday 15:45 to 23:55 instead of 15:15 (8h10, not 8h40); Saturday 15:15 instead of 14:45 (8h40, not 9h10); Sunday 15:15 to 23:25 instead of 14:30 (8h10, not 8h55). Be upfront about the six minutes on the average: that is what pays for working two fewer days a year. If asked: there is also a weekday 14:30–23:25, five a week — the same times as today’s Sunday closer, so it is not new, and it finishes half an hour before the close.</a:t>
+              <a:t>Lead with the closers: they are the shifts people dislike most, and every one of them is shorter. Weekday 15:45 to 23:55 instead of 15:15 (8h 10m, not 8h 40m); Saturday 15:15 instead of 14:45 (8h 40m, not 9h 10m); Sunday 15:15 to 23:25 instead of 14:30 (8h 10m, not 8h 55m). Be upfront about the six minutes on the average: that is what pays for working two fewer days a year. If asked: there is also a weekday 14:30–23:25, five a week — the same times as today’s Sunday closer, so it is not new, and it finishes half an hour before the close.</a:t>
             </a:r>
             <a:endParaRPr lang="en-US" dirty="0"/>
           </a:p>
@@ -1572,7 +1572,7 @@
           <a:p>
             <a:r>
               <a:rPr lang="en-US" dirty="0"/>
-              <a:t>Be straight about this one — it is the change people will notice most. December needs three on duty to the close and five still on at 22:00, where today has two and four, so more late finishes have to go somewhere. Spread over 24 people that is about 20 more a year each finishing at 23:00 or later. Early 06:20 starts hardly change. And because the shortest gap between two shifts is 14h20, nobody finishes late and starts early the next morning.</a:t>
+              <a:t>Be straight about this one — it is the change people will notice most. December needs three on duty to the close and five still on at 22:00, where today has two and four, so more late finishes have to go somewhere. Spread over 24 people that is about 20 more a year each finishing at 23:00 or later. Early 06:20 starts hardly change. And because the shortest gap between two shifts is 14h 20m, nobody finishes late and starts early the next morning.</a:t>
             </a:r>
             <a:endParaRPr lang="en-US" dirty="0"/>
           </a:p>
@@ -6311,7 +6311,7 @@
                           <a:ea typeface="Inter" pitchFamily="34" charset="-122"/>
                           <a:cs typeface="Inter" pitchFamily="34" charset="-120"/>
                         </a:rPr>
-                        <a:t>8h14 · 9h10</a:t>
+                        <a:t>8h 14m · 9h 10m</a:t>
                       </a:r>
                       <a:endParaRPr lang="en-US" sz="1200" dirty="0">
                         <a:latin typeface="Inter" charset="0"/>
@@ -6379,7 +6379,7 @@
                           <a:ea typeface="Inter" pitchFamily="34" charset="-122"/>
                           <a:cs typeface="Inter" pitchFamily="34" charset="-120"/>
                         </a:rPr>
-                        <a:t>8h20 · 9h00</a:t>
+                        <a:t>8h 20m · 9h 00m</a:t>
                       </a:r>
                       <a:endParaRPr lang="en-US" sz="1200" dirty="0">
                         <a:latin typeface="Inter" charset="0"/>
@@ -6517,7 +6517,7 @@
                           <a:ea typeface="Inter" pitchFamily="34" charset="-122"/>
                           <a:cs typeface="Inter" pitchFamily="34" charset="-120"/>
                         </a:rPr>
-                        <a:t>8h40 · 9h10 · 8h55</a:t>
+                        <a:t>8h 40m · 9h 10m · 8h 55m</a:t>
                       </a:r>
                       <a:endParaRPr lang="en-US" sz="1200" dirty="0">
                         <a:latin typeface="Inter" charset="0"/>
@@ -6585,7 +6585,7 @@
                           <a:ea typeface="Inter" pitchFamily="34" charset="-122"/>
                           <a:cs typeface="Inter" pitchFamily="34" charset="-120"/>
                         </a:rPr>
-                        <a:t>8h10 · 8h40 · 8h10</a:t>
+                        <a:t>8h 10m · 8h 40m · 8h 10m</a:t>
                       </a:r>
                       <a:endParaRPr lang="en-US" sz="1200" dirty="0">
                         <a:latin typeface="Inter" charset="0"/>
@@ -7135,7 +7135,7 @@
                           <a:ea typeface="Inter" pitchFamily="34" charset="-122"/>
                           <a:cs typeface="Inter" pitchFamily="34" charset="-120"/>
                         </a:rPr>
-                        <a:t>12h30</a:t>
+                        <a:t>12h 30m</a:t>
                       </a:r>
                       <a:endParaRPr lang="en-US" sz="1200" dirty="0">
                         <a:latin typeface="Inter" charset="0"/>
@@ -7203,7 +7203,7 @@
                           <a:ea typeface="Inter" pitchFamily="34" charset="-122"/>
                           <a:cs typeface="Inter" pitchFamily="34" charset="-120"/>
                         </a:rPr>
-                        <a:t>14h20</a:t>
+                        <a:t>14h 20m</a:t>
                       </a:r>
                       <a:endParaRPr lang="en-US" sz="1200" dirty="0">
                         <a:latin typeface="Inter" charset="0"/>
@@ -11568,7 +11568,7 @@
                 <a:ea typeface="Inter" pitchFamily="34" charset="-122"/>
                 <a:cs typeface="Inter" pitchFamily="34" charset="-120"/>
               </a:rPr>
-              <a:t>8h40</a:t>
+              <a:t>8h 40m</a:t>
             </a:r>
             <a:endParaRPr lang="en-US" sz="1600" dirty="0"/>
           </a:p>
@@ -11607,7 +11607,7 @@
                 <a:ea typeface="Inter" pitchFamily="34" charset="-122"/>
                 <a:cs typeface="Inter" pitchFamily="34" charset="-120"/>
               </a:rPr>
-              <a:t>8h10</a:t>
+              <a:t>8h 10m</a:t>
             </a:r>
             <a:endParaRPr lang="en-US" sz="1800" dirty="0"/>
           </a:p>
@@ -11712,7 +11712,7 @@
                 <a:ea typeface="Inter" pitchFamily="34" charset="-122"/>
                 <a:cs typeface="Inter" pitchFamily="34" charset="-120"/>
               </a:rPr>
-              <a:t>9h10</a:t>
+              <a:t>9h 10m</a:t>
             </a:r>
             <a:endParaRPr lang="en-US" sz="1600" dirty="0"/>
           </a:p>
@@ -11751,7 +11751,7 @@
                 <a:ea typeface="Inter" pitchFamily="34" charset="-122"/>
                 <a:cs typeface="Inter" pitchFamily="34" charset="-120"/>
               </a:rPr>
-              <a:t>8h40</a:t>
+              <a:t>8h 40m</a:t>
             </a:r>
             <a:endParaRPr lang="en-US" sz="1800" dirty="0"/>
           </a:p>
@@ -11856,7 +11856,7 @@
                 <a:ea typeface="Inter" pitchFamily="34" charset="-122"/>
                 <a:cs typeface="Inter" pitchFamily="34" charset="-120"/>
               </a:rPr>
-              <a:t>8h55</a:t>
+              <a:t>8h 55m</a:t>
             </a:r>
             <a:endParaRPr lang="en-US" sz="1600" dirty="0"/>
           </a:p>
@@ -11895,7 +11895,7 @@
                 <a:ea typeface="Inter" pitchFamily="34" charset="-122"/>
                 <a:cs typeface="Inter" pitchFamily="34" charset="-120"/>
               </a:rPr>
-              <a:t>8h10</a:t>
+              <a:t>8h 10m</a:t>
             </a:r>
             <a:endParaRPr lang="en-US" sz="1800" dirty="0"/>
           </a:p>
@@ -12000,7 +12000,7 @@
                 <a:ea typeface="Inter" pitchFamily="34" charset="-122"/>
                 <a:cs typeface="Inter" pitchFamily="34" charset="-120"/>
               </a:rPr>
-              <a:t>9h10</a:t>
+              <a:t>9h 10m</a:t>
             </a:r>
             <a:endParaRPr lang="en-US" sz="1600" dirty="0"/>
           </a:p>
@@ -12039,7 +12039,7 @@
                 <a:ea typeface="Inter" pitchFamily="34" charset="-122"/>
                 <a:cs typeface="Inter" pitchFamily="34" charset="-120"/>
               </a:rPr>
-              <a:t>9h00</a:t>
+              <a:t>9h 00m</a:t>
             </a:r>
             <a:endParaRPr lang="en-US" sz="1800" dirty="0"/>
           </a:p>
@@ -12144,7 +12144,7 @@
                 <a:ea typeface="Inter" pitchFamily="34" charset="-122"/>
                 <a:cs typeface="Inter" pitchFamily="34" charset="-120"/>
               </a:rPr>
-              <a:t>8h14</a:t>
+              <a:t>8h 14m</a:t>
             </a:r>
             <a:endParaRPr lang="en-US" sz="1600" dirty="0"/>
           </a:p>
@@ -12183,7 +12183,7 @@
                 <a:ea typeface="Inter" pitchFamily="34" charset="-122"/>
                 <a:cs typeface="Inter" pitchFamily="34" charset="-120"/>
               </a:rPr>
-              <a:t>8h20</a:t>
+              <a:t>8h 20m</a:t>
             </a:r>
             <a:endParaRPr lang="en-US" sz="1800" dirty="0"/>
           </a:p>
@@ -13013,7 +13013,7 @@
                 <a:ea typeface="Inter" pitchFamily="34" charset="-122"/>
                 <a:cs typeface="Inter" pitchFamily="34" charset="-120"/>
               </a:rPr>
-              <a:t>12h30</a:t>
+              <a:t>12h 30m</a:t>
             </a:r>
             <a:endParaRPr lang="en-US" sz="1600" dirty="0"/>
           </a:p>
@@ -13052,7 +13052,7 @@
                 <a:ea typeface="Inter" pitchFamily="34" charset="-122"/>
                 <a:cs typeface="Inter" pitchFamily="34" charset="-120"/>
               </a:rPr>
-              <a:t>14h20</a:t>
+              <a:t>14h 20m</a:t>
             </a:r>
             <a:endParaRPr lang="en-US" sz="1800" dirty="0"/>
           </a:p>
@@ -13409,7 +13409,7 @@
           <a:bodyPr wrap="square" lIns="0" tIns="0" rIns="0" bIns="0" rtlCol="0" anchor="t"/>
           <a:lstStyle/>
           <a:p>
-            <a:pPr marL="342900" indent="-342900">
+            <a:pPr marL="152400" indent="-152400">
               <a:spcAft>
                 <a:spcPts val="200"/>
               </a:spcAft>
@@ -13430,7 +13430,7 @@
             <a:endParaRPr lang="en-US" sz="1200" dirty="0"/>
           </a:p>
           <a:p>
-            <a:pPr marL="342900" indent="-342900">
+            <a:pPr marL="152400" indent="-152400">
               <a:spcAft>
                 <a:spcPts val="200"/>
               </a:spcAft>
@@ -13451,7 +13451,7 @@
             <a:endParaRPr lang="en-US" sz="1200" dirty="0"/>
           </a:p>
           <a:p>
-            <a:pPr marL="342900" indent="-342900">
+            <a:pPr marL="152400" indent="-152400">
               <a:spcAft>
                 <a:spcPts val="200"/>
               </a:spcAft>
@@ -13472,7 +13472,7 @@
             <a:endParaRPr lang="en-US" sz="1200" dirty="0"/>
           </a:p>
           <a:p>
-            <a:pPr marL="342900" indent="-342900">
+            <a:pPr marL="152400" indent="-152400">
               <a:spcAft>
                 <a:spcPts val="200"/>
               </a:spcAft>
@@ -13650,7 +13650,7 @@
             <a:endParaRPr lang="en-US" sz="1050" dirty="0"/>
           </a:p>
           <a:p>
-            <a:pPr marL="342900" indent="-342900">
+            <a:pPr marL="152400" indent="-152400">
               <a:spcAft>
                 <a:spcPts val="100"/>
               </a:spcAft>
@@ -13671,7 +13671,7 @@
             <a:endParaRPr lang="en-US" sz="1050" dirty="0"/>
           </a:p>
           <a:p>
-            <a:pPr marL="342900" indent="-342900">
+            <a:pPr marL="152400" indent="-152400">
               <a:spcAft>
                 <a:spcPts val="100"/>
               </a:spcAft>
@@ -13715,7 +13715,7 @@
             <a:endParaRPr lang="en-US" sz="1050" dirty="0"/>
           </a:p>
           <a:p>
-            <a:pPr marL="342900" indent="-342900">
+            <a:pPr marL="152400" indent="-152400">
               <a:spcAft>
                 <a:spcPts val="100"/>
               </a:spcAft>
@@ -13736,7 +13736,7 @@
             <a:endParaRPr lang="en-US" sz="1050" dirty="0"/>
           </a:p>
           <a:p>
-            <a:pPr marL="342900" indent="-342900">
+            <a:pPr marL="152400" indent="-152400">
               <a:spcAft>
                 <a:spcPts val="100"/>
               </a:spcAft>
@@ -13780,7 +13780,7 @@
             <a:endParaRPr lang="en-US" sz="1050" dirty="0"/>
           </a:p>
           <a:p>
-            <a:pPr marL="342900" indent="-342900">
+            <a:pPr marL="152400" indent="-152400">
               <a:spcAft>
                 <a:spcPts val="100"/>
               </a:spcAft>
@@ -13801,7 +13801,7 @@
             <a:endParaRPr lang="en-US" sz="1050" dirty="0"/>
           </a:p>
           <a:p>
-            <a:pPr marL="342900" indent="-342900">
+            <a:pPr marL="152400" indent="-152400">
               <a:spcAft>
                 <a:spcPts val="100"/>
               </a:spcAft>
@@ -13822,7 +13822,7 @@
             <a:endParaRPr lang="en-US" sz="1050" dirty="0"/>
           </a:p>
           <a:p>
-            <a:pPr marL="342900" indent="-342900">
+            <a:pPr marL="152400" indent="-152400">
               <a:spcAft>
                 <a:spcPts val="100"/>
               </a:spcAft>
@@ -13843,7 +13843,7 @@
             <a:endParaRPr lang="en-US" sz="1050" dirty="0"/>
           </a:p>
           <a:p>
-            <a:pPr marL="342900" indent="-342900">
+            <a:pPr marL="152400" indent="-152400">
               <a:spcAft>
                 <a:spcPts val="100"/>
               </a:spcAft>
@@ -14689,7 +14689,7 @@
                 <a:ea typeface="Inter" pitchFamily="34" charset="-122"/>
                 <a:cs typeface="Inter" pitchFamily="34" charset="-120"/>
               </a:rPr>
-              <a:t>12h30</a:t>
+              <a:t>12h 30m</a:t>
             </a:r>
             <a:endParaRPr lang="en-US" sz="1600" dirty="0"/>
           </a:p>
@@ -14728,7 +14728,7 @@
                 <a:ea typeface="Inter" pitchFamily="34" charset="-122"/>
                 <a:cs typeface="Inter" pitchFamily="34" charset="-120"/>
               </a:rPr>
-              <a:t>14h20</a:t>
+              <a:t>14h 20m</a:t>
             </a:r>
             <a:endParaRPr lang="en-US" sz="1800" dirty="0"/>
           </a:p>
@@ -14794,7 +14794,7 @@
                 <a:ea typeface="Inter" pitchFamily="34" charset="-122"/>
                 <a:cs typeface="Inter" pitchFamily="34" charset="-120"/>
               </a:rPr>
-              <a:t>Weeks all earlies or all lates, one shift time Mon–Fri</a:t>
+              <a:t>Weeks on one turn, Monday to Friday</a:t>
             </a:r>
             <a:endParaRPr lang="en-US" sz="1400" dirty="0"/>
           </a:p>

</xml_diff>

<commit_message>
Colleague decks: slide polish from a screenshot check
Right Away slide 13 and both decks' trade-off cards no longer leave a
single word on a line of its own. No figure changes. The zip is rebuilt.

Co-Authored-By: Claude Opus 5.5 <noreply@anthropic.com>
Claude-Session: https://claude.ai/code/session_01MrfcTRinN39zgr6tpkue66
</commit_message>
<xml_diff>
--- a/docs/proposals/presentations/Familiar-Nine-for-colleagues.pptx
+++ b/docs/proposals/presentations/Familiar-Nine-for-colleagues.pptx
@@ -5121,7 +5121,7 @@
                 <a:ea typeface="Inter" pitchFamily="34" charset="-122"/>
                 <a:cs typeface="Inter" pitchFamily="34" charset="-120"/>
               </a:rPr>
-              <a:t>On average and at worst, about the same as today.</a:t>
+              <a:t>Average and worst: about the same as today.</a:t>
             </a:r>
             <a:endParaRPr lang="en-US" sz="1250" dirty="0"/>
           </a:p>
@@ -5226,7 +5226,7 @@
                 <a:ea typeface="Inter" pitchFamily="34" charset="-122"/>
                 <a:cs typeface="Inter" pitchFamily="34" charset="-120"/>
               </a:rPr>
-              <a:t>Now evenly spaced — every sixth week (1, 7, 13, 19).</a:t>
+              <a:t>Evenly spaced — every sixth week (1, 7, 13, 19).</a:t>
             </a:r>
             <a:endParaRPr lang="en-US" sz="1250" dirty="0"/>
           </a:p>

</xml_diff>

<commit_message>
Links pack: accuracy-audit fixes to the four presentations, README and zip
- "More people on duty with you, all day" was false at some hours; now
  "more people rostered every day, at the open and the close"
- Late finishes only partly from the December rules (about 6.5 of ~20 a year each)
- "Contract paid exactly" -> "rostered exactly, on average"; "more full weekends off";
  four weeks' leave "at best"; a cover week "at most 4 days"; "confirmed verbally";
  Sunday 23:25 "agreed practice (settled 28 Sep 2026)"; today's link four warnings in the
  fixed rota (up to five); Right Away's match worded as a score
- README records the audit; the zip carries every corrected file and the current README

Co-Authored-By: Claude Opus 5.5 <noreply@anthropic.com>
Claude-Session: https://claude.ai/code/session_01MrfcTRinN39zgr6tpkue66
</commit_message>
<xml_diff>
--- a/docs/proposals/presentations/Familiar-Nine-for-colleagues.pptx
+++ b/docs/proposals/presentations/Familiar-Nine-for-colleagues.pptx
@@ -692,7 +692,7 @@
           <a:p>
             <a:r>
               <a:rPr lang="en-US" dirty="0"/>
-              <a:t>Leave is only needed on working days Monday to Saturday; rest days and Sundays cost nothing. Today there is one unusual stretch of the roster where 14 days buys 30 days off — Familiar Nine spreads rest days more evenly, so its best is 28. On average it is about the same, and at its worst it is never worse than today. Four full weeks off (Sunday to Saturday) takes 15 days of leave instead of 14. The exact averages depend on where you count a booking as starting, so quote them as “about the same”.</a:t>
+              <a:t>Leave is only needed on working days Monday to Saturday; rest days and Sundays cost nothing. Today there is one unusual stretch of the roster where 14 days buys 30 days off — Familiar Nine spreads rest days more evenly, so its best is 28. On average it is about the same, and at its worst it is never worse than today. Four full weeks off (Sunday to Saturday) takes at least 15 days of leave, instead of 14 at best today. The exact averages depend on where you count a booking as starting, so quote them as “about the same”.</a:t>
             </a:r>
             <a:endParaRPr lang="en-US" dirty="0"/>
           </a:p>
@@ -780,7 +780,7 @@
           <a:p>
             <a:r>
               <a:rPr lang="en-US" dirty="0"/>
-              <a:t>The Office of Rail and Road and the rail industry publish lists of rota patterns that tend to tire people. Today’s link shows five of them; Familiar Nine shows none. Two more — early starts and a weekly rotation — come with every weekly link at a 06:20 station, so they are listed on the sheet for information but not counted against any design.</a:t>
+              <a:t>The Office of Rail and Road and the rail industry publish lists of rota patterns that tend to tire people. Today’s link shows four of them in the fixed rota (up to five where a cover week falls badly); Familiar Nine shows none. Two more — early starts and a weekly rotation — come with every weekly link at a 06:20 station, so they are listed on the sheet for information but not counted against any design.</a:t>
             </a:r>
             <a:endParaRPr lang="en-US" dirty="0"/>
           </a:p>
@@ -1132,7 +1132,7 @@
           <a:p>
             <a:r>
               <a:rPr lang="en-US" dirty="0"/>
-              <a:t>This is the whole pitch on one slide. Same 35-hour week as now. Never more than six days in a row. One full weekend off in every four weeks, against one in five today. Eight of the sixteen shift times are ones people already work. And every closing shift is shorter: the weekday and Saturday closers by 30 minutes, the Sunday closer by 45.</a:t>
+              <a:t>This is the whole pitch on one slide. Same 35-hour week as now. Never more than six days in a row. One full weekend off in every four weeks, against one in five today — though each person works about four more Saturdays a year. Eight of the sixteen shift times are ones people already work. And every closing shift is shorter: the weekday and Saturday closers by 30 minutes, the Sunday closer by 45.</a:t>
             </a:r>
             <a:endParaRPr lang="en-US" dirty="0"/>
           </a:p>
@@ -1220,7 +1220,7 @@
           <a:p>
             <a:r>
               <a:rPr lang="en-US" dirty="0"/>
-              <a:t>The change is coming whatever we do: the December 2026 timetable and the new staffing levels mean the link has to be redrawn. The question is which version we want. The staffing levels, the 24 people and the Sunday cover are confirmed: nine rules the proposal is scored on. Fourteen on a Saturday is one of three flexible aims, worked towards but not scored.</a:t>
+              <a:t>The change is coming whatever we do: the December 2026 timetable and the new staffing levels mean the link has to be redrawn. The question is which version we want. The staffing levels, the 24 people and the Sunday cover were confirmed verbally on 29 September 2026: nine rules the proposal is scored on. Fourteen on a Saturday is one of three flexible aims, worked towards but not scored.</a:t>
             </a:r>
             <a:endParaRPr lang="en-US" dirty="0"/>
           </a:p>
@@ -1572,7 +1572,7 @@
           <a:p>
             <a:r>
               <a:rPr lang="en-US" dirty="0"/>
-              <a:t>Be straight about this one — it is the change people will notice most. December needs three on duty to the close and five still on at 22:00, where today’s weekdays have two and four, so more late finishes have to go somewhere. Spread over 24 people that is about 20 more a year each finishing at 23:00 or later. Early 06:20 starts hardly change. And because the shortest gap between two shifts is 14h 20m, nobody finishes late and starts early the next morning.</a:t>
+              <a:t>Be straight about this one — it is the change people will notice most. About 20 more a year each finish at 23:00 or later. Only part of that is the December rules: three on duty to the close every day, where today’s weekdays have two, adds about six or seven a year each once it is spread over 24 people. The rest comes from how this design places its late shifts, not from the rules, so it is a fair question to ask. Early 06:20 starts hardly change. And because the shortest gap between two shifts is 14h 20m, nobody finishes late and starts early the next morning.</a:t>
             </a:r>
             <a:endParaRPr lang="en-US" dirty="0"/>
           </a:p>
@@ -2853,7 +2853,7 @@
                 <a:ea typeface="Inter" pitchFamily="34" charset="-122"/>
                 <a:cs typeface="Inter" pitchFamily="34" charset="-120"/>
               </a:rPr>
-              <a:t>The Sunday finish stays where it is. That is agreed practice and will remain so.</a:t>
+              <a:t>The Sunday finish stays where it is. That is agreed practice (settled 28 Sep 2026).</a:t>
             </a:r>
             <a:endParaRPr lang="en-US" sz="1300" dirty="0"/>
           </a:p>
@@ -3644,7 +3644,7 @@
                 <a:ea typeface="Inter" pitchFamily="34" charset="-122"/>
                 <a:cs typeface="Inter" pitchFamily="34" charset="-120"/>
               </a:rPr>
-              <a:t>Leave needed for four full weeks off</a:t>
+              <a:t>Leave needed for four full weeks off, at best</a:t>
             </a:r>
             <a:endParaRPr lang="en-US" sz="1400" dirty="0"/>
           </a:p>
@@ -3788,7 +3788,7 @@
                 <a:ea typeface="Inter" pitchFamily="34" charset="-122"/>
                 <a:cs typeface="Inter" pitchFamily="34" charset="-120"/>
               </a:rPr>
-              <a:t>About the same. A cover week still counts as 4 days of leave, exactly as now.</a:t>
+              <a:t>About the same. A cover week still counts as at most 4 days of leave, as now.</a:t>
             </a:r>
             <a:endParaRPr lang="en-US" sz="1400" dirty="0"/>
           </a:p>
@@ -3937,7 +3937,7 @@
                 <a:ea typeface="Inter" pitchFamily="34" charset="-122"/>
                 <a:cs typeface="Inter" pitchFamily="34" charset="-120"/>
               </a:rPr>
-              <a:t>More people on duty with you, all day</a:t>
+              <a:t>More people rostered every day, at the open and the close</a:t>
             </a:r>
             <a:endParaRPr lang="en-US" sz="1500" dirty="0"/>
           </a:p>
@@ -7937,7 +7937,7 @@
                 <a:ea typeface="Inter" pitchFamily="34" charset="-122"/>
                 <a:cs typeface="Inter" pitchFamily="34" charset="-120"/>
               </a:rPr>
-              <a:t>Same hours, fewer contracted days, shorter closers, more weekends, more colleagues.</a:t>
+              <a:t>Same hours, fewer contracted days, shorter closers, more full weekends off, more colleagues.</a:t>
             </a:r>
             <a:endParaRPr lang="en-US" sz="1400" dirty="0"/>
           </a:p>
@@ -9129,7 +9129,7 @@
                 <a:ea typeface="Inter" pitchFamily="34" charset="-122"/>
                 <a:cs typeface="Inter" pitchFamily="34" charset="-120"/>
               </a:rPr>
-              <a:t>Same hours, shorter closing shifts, more weekends — and half the times already familiar.</a:t>
+              <a:t>Same hours, shorter closing shifts, more full weekends off — and half the times already familiar.</a:t>
             </a:r>
             <a:endParaRPr lang="en-US" sz="1400" dirty="0"/>
           </a:p>
@@ -13157,7 +13157,7 @@
                 <a:ea typeface="Inter" pitchFamily="34" charset="-122"/>
                 <a:cs typeface="Inter" pitchFamily="34" charset="-120"/>
               </a:rPr>
-              <a:t>December needs more people at the close — but every closing shift is shorter.</a:t>
+              <a:t>More late finishes, only partly from the December rules — but every closing shift is shorter.</a:t>
             </a:r>
             <a:endParaRPr lang="en-US" sz="1400" dirty="0"/>
           </a:p>

</xml_diff>

<commit_message>
Links pack: screenshot polish of the sheets, summary, rules sheet and presentations
No figure changed. Sheets: one accent per card on page 1's four tiles; top bars square on
their own side; no lone last words; no line-starting separator dots; clock ranges with an
en dash everywhere; page 2 day keys on their own line; page 6 set larger to use its empty
third, with its two blank rule notes filled; page 1 shares spare room between sections.
Summary: "up to" notes grey. Rules sheet: basics flow in two columns. Decks: five taglines
and one table label fit on one line; the two half-empty slides use the slide.

Co-Authored-By: Claude Opus 5.5 <noreply@anthropic.com>
Claude-Session: https://claude.ai/code/session_01MrfcTRinN39zgr6tpkue66
</commit_message>
<xml_diff>
--- a/docs/proposals/presentations/Familiar-Nine-for-colleagues.pptx
+++ b/docs/proposals/presentations/Familiar-Nine-for-colleagues.pptx
@@ -3644,7 +3644,7 @@
                 <a:ea typeface="Inter" pitchFamily="34" charset="-122"/>
                 <a:cs typeface="Inter" pitchFamily="34" charset="-120"/>
               </a:rPr>
-              <a:t>Leave needed for four full weeks off, at best</a:t>
+              <a:t>Leave for four full weeks off, at best</a:t>
             </a:r>
             <a:endParaRPr lang="en-US" sz="1400" dirty="0"/>
           </a:p>
@@ -4821,7 +4821,7 @@
         <p:spPr>
           <a:xfrm>
             <a:off x="457200" y="1371600"/>
-            <a:ext cx="4023360" cy="804672"/>
+            <a:ext cx="4023360" cy="975272"/>
           </a:xfrm>
           <a:prstGeom prst="roundRect">
             <a:avLst>
@@ -4847,7 +4847,7 @@
         </p:nvSpPr>
         <p:spPr>
           <a:xfrm>
-            <a:off x="640080" y="1444752"/>
+            <a:off x="640080" y="1530052"/>
             <a:ext cx="3703320" cy="310896"/>
           </a:xfrm>
           <a:prstGeom prst="rect">
@@ -4886,7 +4886,7 @@
         </p:nvSpPr>
         <p:spPr>
           <a:xfrm>
-            <a:off x="640080" y="1755648"/>
+            <a:off x="640080" y="1840948"/>
             <a:ext cx="3657600" cy="347472"/>
           </a:xfrm>
           <a:prstGeom prst="rect">
@@ -4896,7 +4896,7 @@
           <a:ln/>
         </p:spPr>
         <p:txBody>
-          <a:bodyPr wrap="square" lIns="0" tIns="0" rIns="0" bIns="0" rtlCol="0" anchor="ctr"/>
+          <a:bodyPr anchor="t" wrap="square" lIns="0" tIns="0" rIns="0" bIns="0" rtlCol="0"/>
           <a:lstStyle/>
           <a:p>
             <a:pPr indent="0" marL="0">
@@ -4926,7 +4926,7 @@
         <p:spPr>
           <a:xfrm>
             <a:off x="4663440" y="1371600"/>
-            <a:ext cx="4023360" cy="804672"/>
+            <a:ext cx="4023360" cy="975272"/>
           </a:xfrm>
           <a:prstGeom prst="roundRect">
             <a:avLst>
@@ -4952,7 +4952,7 @@
         </p:nvSpPr>
         <p:spPr>
           <a:xfrm>
-            <a:off x="4846320" y="1444752"/>
+            <a:off x="4846320" y="1530052"/>
             <a:ext cx="3703320" cy="310896"/>
           </a:xfrm>
           <a:prstGeom prst="rect">
@@ -4991,7 +4991,7 @@
         </p:nvSpPr>
         <p:spPr>
           <a:xfrm>
-            <a:off x="4846320" y="1755648"/>
+            <a:off x="4846320" y="1840948"/>
             <a:ext cx="3657600" cy="347472"/>
           </a:xfrm>
           <a:prstGeom prst="rect">
@@ -5001,7 +5001,7 @@
           <a:ln/>
         </p:spPr>
         <p:txBody>
-          <a:bodyPr wrap="square" lIns="0" tIns="0" rIns="0" bIns="0" rtlCol="0" anchor="ctr"/>
+          <a:bodyPr anchor="t" wrap="square" lIns="0" tIns="0" rIns="0" bIns="0" rtlCol="0"/>
           <a:lstStyle/>
           <a:p>
             <a:pPr indent="0" marL="0">
@@ -5030,8 +5030,8 @@
         </p:nvSpPr>
         <p:spPr>
           <a:xfrm>
-            <a:off x="457200" y="2286000"/>
-            <a:ext cx="4023360" cy="804672"/>
+            <a:off x="457200" y="2456600"/>
+            <a:ext cx="4023360" cy="975272"/>
           </a:xfrm>
           <a:prstGeom prst="roundRect">
             <a:avLst>
@@ -5057,7 +5057,7 @@
         </p:nvSpPr>
         <p:spPr>
           <a:xfrm>
-            <a:off x="640080" y="2359152"/>
+            <a:off x="640080" y="2615052"/>
             <a:ext cx="3703320" cy="310896"/>
           </a:xfrm>
           <a:prstGeom prst="rect">
@@ -5096,7 +5096,7 @@
         </p:nvSpPr>
         <p:spPr>
           <a:xfrm>
-            <a:off x="640080" y="2670048"/>
+            <a:off x="640080" y="2925948"/>
             <a:ext cx="3657600" cy="347472"/>
           </a:xfrm>
           <a:prstGeom prst="rect">
@@ -5106,7 +5106,7 @@
           <a:ln/>
         </p:spPr>
         <p:txBody>
-          <a:bodyPr wrap="square" lIns="0" tIns="0" rIns="0" bIns="0" rtlCol="0" anchor="ctr"/>
+          <a:bodyPr anchor="t" wrap="square" lIns="0" tIns="0" rIns="0" bIns="0" rtlCol="0"/>
           <a:lstStyle/>
           <a:p>
             <a:pPr indent="0" marL="0">
@@ -5135,8 +5135,8 @@
         </p:nvSpPr>
         <p:spPr>
           <a:xfrm>
-            <a:off x="4663440" y="2286000"/>
-            <a:ext cx="4023360" cy="804672"/>
+            <a:off x="4663440" y="2456600"/>
+            <a:ext cx="4023360" cy="975272"/>
           </a:xfrm>
           <a:prstGeom prst="roundRect">
             <a:avLst>
@@ -5162,7 +5162,7 @@
         </p:nvSpPr>
         <p:spPr>
           <a:xfrm>
-            <a:off x="4846320" y="2359152"/>
+            <a:off x="4846320" y="2615052"/>
             <a:ext cx="3703320" cy="310896"/>
           </a:xfrm>
           <a:prstGeom prst="rect">
@@ -5201,7 +5201,7 @@
         </p:nvSpPr>
         <p:spPr>
           <a:xfrm>
-            <a:off x="4846320" y="2670048"/>
+            <a:off x="4846320" y="2925948"/>
             <a:ext cx="3657600" cy="347472"/>
           </a:xfrm>
           <a:prstGeom prst="rect">
@@ -5211,7 +5211,7 @@
           <a:ln/>
         </p:spPr>
         <p:txBody>
-          <a:bodyPr wrap="square" lIns="0" tIns="0" rIns="0" bIns="0" rtlCol="0" anchor="ctr"/>
+          <a:bodyPr anchor="t" wrap="square" lIns="0" tIns="0" rIns="0" bIns="0" rtlCol="0"/>
           <a:lstStyle/>
           <a:p>
             <a:pPr indent="0" marL="0">
@@ -5240,8 +5240,8 @@
         </p:nvSpPr>
         <p:spPr>
           <a:xfrm>
-            <a:off x="457200" y="3200400"/>
-            <a:ext cx="4023360" cy="804672"/>
+            <a:off x="457200" y="3541600"/>
+            <a:ext cx="4023360" cy="975272"/>
           </a:xfrm>
           <a:prstGeom prst="roundRect">
             <a:avLst>
@@ -5267,7 +5267,7 @@
         </p:nvSpPr>
         <p:spPr>
           <a:xfrm>
-            <a:off x="640080" y="3273552"/>
+            <a:off x="640080" y="3700052"/>
             <a:ext cx="3703320" cy="310896"/>
           </a:xfrm>
           <a:prstGeom prst="rect">
@@ -5306,7 +5306,7 @@
         </p:nvSpPr>
         <p:spPr>
           <a:xfrm>
-            <a:off x="640080" y="3584448"/>
+            <a:off x="640080" y="4010948"/>
             <a:ext cx="3657600" cy="347472"/>
           </a:xfrm>
           <a:prstGeom prst="rect">
@@ -5316,7 +5316,7 @@
           <a:ln/>
         </p:spPr>
         <p:txBody>
-          <a:bodyPr wrap="square" lIns="0" tIns="0" rIns="0" bIns="0" rtlCol="0" anchor="ctr"/>
+          <a:bodyPr anchor="t" wrap="square" lIns="0" tIns="0" rIns="0" bIns="0" rtlCol="0"/>
           <a:lstStyle/>
           <a:p>
             <a:pPr indent="0" marL="0">
@@ -5345,8 +5345,8 @@
         </p:nvSpPr>
         <p:spPr>
           <a:xfrm>
-            <a:off x="4663440" y="3200400"/>
-            <a:ext cx="4023360" cy="804672"/>
+            <a:off x="4663440" y="3541600"/>
+            <a:ext cx="4023360" cy="975272"/>
           </a:xfrm>
           <a:prstGeom prst="roundRect">
             <a:avLst>
@@ -5372,7 +5372,7 @@
         </p:nvSpPr>
         <p:spPr>
           <a:xfrm>
-            <a:off x="4846320" y="3273552"/>
+            <a:off x="4846320" y="3700052"/>
             <a:ext cx="3703320" cy="310896"/>
           </a:xfrm>
           <a:prstGeom prst="rect">
@@ -5411,7 +5411,7 @@
         </p:nvSpPr>
         <p:spPr>
           <a:xfrm>
-            <a:off x="4846320" y="3584448"/>
+            <a:off x="4846320" y="4010948"/>
             <a:ext cx="3657600" cy="347472"/>
           </a:xfrm>
           <a:prstGeom prst="rect">
@@ -5421,7 +5421,7 @@
           <a:ln/>
         </p:spPr>
         <p:txBody>
-          <a:bodyPr wrap="square" lIns="0" tIns="0" rIns="0" bIns="0" rtlCol="0" anchor="ctr"/>
+          <a:bodyPr anchor="t" wrap="square" lIns="0" tIns="0" rIns="0" bIns="0" rtlCol="0"/>
           <a:lstStyle/>
           <a:p>
             <a:pPr indent="0" marL="0">
@@ -7937,7 +7937,7 @@
                 <a:ea typeface="Inter" pitchFamily="34" charset="-122"/>
                 <a:cs typeface="Inter" pitchFamily="34" charset="-120"/>
               </a:rPr>
-              <a:t>Same hours, fewer contracted days, shorter closers, more full weekends off, more colleagues.</a:t>
+              <a:t>Same hours, fewer contracted days, shorter closers, more full weekends off.</a:t>
             </a:r>
             <a:endParaRPr lang="en-US" sz="1400" dirty="0"/>
           </a:p>
@@ -9129,7 +9129,7 @@
                 <a:ea typeface="Inter" pitchFamily="34" charset="-122"/>
                 <a:cs typeface="Inter" pitchFamily="34" charset="-120"/>
               </a:rPr>
-              <a:t>Same hours, shorter closing shifts, more full weekends off — and half the times already familiar.</a:t>
+              <a:t>Same hours, shorter closers, more full weekends off — and half the times familiar.</a:t>
             </a:r>
             <a:endParaRPr lang="en-US" sz="1400" dirty="0"/>
           </a:p>
@@ -9419,7 +9419,7 @@
         </p:nvSpPr>
         <p:spPr>
           <a:xfrm>
-            <a:off x="457200" y="2029968"/>
+            <a:off x="457200" y="2233968"/>
             <a:ext cx="457200" cy="457200"/>
           </a:xfrm>
           <a:prstGeom prst="ellipse">
@@ -9452,7 +9452,7 @@
         </p:blipFill>
         <p:spPr>
           <a:xfrm>
-            <a:off x="557784" y="2130552"/>
+            <a:off x="557784" y="2334552"/>
             <a:ext cx="256032" cy="256032"/>
           </a:xfrm>
           <a:prstGeom prst="rect">
@@ -9468,7 +9468,7 @@
         </p:nvSpPr>
         <p:spPr>
           <a:xfrm>
-            <a:off x="1097280" y="1993392"/>
+            <a:off x="1097280" y="2197392"/>
             <a:ext cx="7589520" cy="292608"/>
           </a:xfrm>
           <a:prstGeom prst="rect">
@@ -9507,7 +9507,7 @@
         </p:nvSpPr>
         <p:spPr>
           <a:xfrm>
-            <a:off x="1097280" y="2276856"/>
+            <a:off x="1097280" y="2480856"/>
             <a:ext cx="7589520" cy="274320"/>
           </a:xfrm>
           <a:prstGeom prst="rect">
@@ -9546,7 +9546,7 @@
         </p:nvSpPr>
         <p:spPr>
           <a:xfrm>
-            <a:off x="457200" y="2688336"/>
+            <a:off x="457200" y="3096336"/>
             <a:ext cx="457200" cy="457200"/>
           </a:xfrm>
           <a:prstGeom prst="ellipse">
@@ -9579,7 +9579,7 @@
         </p:blipFill>
         <p:spPr>
           <a:xfrm>
-            <a:off x="557784" y="2788920"/>
+            <a:off x="557784" y="3196920"/>
             <a:ext cx="256032" cy="256032"/>
           </a:xfrm>
           <a:prstGeom prst="rect">
@@ -9595,7 +9595,7 @@
         </p:nvSpPr>
         <p:spPr>
           <a:xfrm>
-            <a:off x="1097280" y="2651760"/>
+            <a:off x="1097280" y="3059760"/>
             <a:ext cx="7589520" cy="292608"/>
           </a:xfrm>
           <a:prstGeom prst="rect">
@@ -9634,7 +9634,7 @@
         </p:nvSpPr>
         <p:spPr>
           <a:xfrm>
-            <a:off x="1097280" y="2935224"/>
+            <a:off x="1097280" y="3343224"/>
             <a:ext cx="7589520" cy="274320"/>
           </a:xfrm>
           <a:prstGeom prst="rect">
@@ -9673,7 +9673,7 @@
         </p:nvSpPr>
         <p:spPr>
           <a:xfrm>
-            <a:off x="457200" y="3346704"/>
+            <a:off x="457200" y="3958704"/>
             <a:ext cx="457200" cy="457200"/>
           </a:xfrm>
           <a:prstGeom prst="ellipse">
@@ -9706,7 +9706,7 @@
         </p:blipFill>
         <p:spPr>
           <a:xfrm>
-            <a:off x="557784" y="3447288"/>
+            <a:off x="557784" y="4059288"/>
             <a:ext cx="256032" cy="256032"/>
           </a:xfrm>
           <a:prstGeom prst="rect">
@@ -9722,7 +9722,7 @@
         </p:nvSpPr>
         <p:spPr>
           <a:xfrm>
-            <a:off x="1097280" y="3310128"/>
+            <a:off x="1097280" y="3922128"/>
             <a:ext cx="7589520" cy="292608"/>
           </a:xfrm>
           <a:prstGeom prst="rect">
@@ -9761,7 +9761,7 @@
         </p:nvSpPr>
         <p:spPr>
           <a:xfrm>
-            <a:off x="1097280" y="3593592"/>
+            <a:off x="1097280" y="4205592"/>
             <a:ext cx="7589520" cy="274320"/>
           </a:xfrm>
           <a:prstGeom prst="rect">
@@ -13157,7 +13157,7 @@
                 <a:ea typeface="Inter" pitchFamily="34" charset="-122"/>
                 <a:cs typeface="Inter" pitchFamily="34" charset="-120"/>
               </a:rPr>
-              <a:t>More late finishes, only partly from the December rules — but every closing shift is shorter.</a:t>
+              <a:t>More late finishes, only partly from the rules — but every closing shift is shorter.</a:t>
             </a:r>
             <a:endParaRPr lang="en-US" sz="1400" dirty="0"/>
           </a:p>

</xml_diff>